<commit_message>
Slides: drop the Compose promise in sd-13-013 and the clean-runner claim in sd-13-014
Co-Authored-By: Claude Opus 5.5 <noreply@anthropic.com>
Claude-Session: https://claude.ai/code/session_01TQmrJYLm4GPgtXpQaEk7ey
</commit_message>
<xml_diff>
--- a/system-design-101/vi/lessons/sd-13-013/slides/sd-13-013.pptx
+++ b/system-design-101/vi/lessons/sd-13-013/slides/sd-13-013.pptx
@@ -5327,6 +5327,61 @@
               <a:buNone/>
             </a:pPr>
             <a:r>
+              <a:rPr lang="en-US" sz="2550" dirty="0" spc="2" kern="0">
+                <a:solidFill>
+                  <a:srgbClr val="14161C"/>
+                </a:solidFill>
+                <a:latin typeface="Be Vietnam Pro" pitchFamily="34" charset="0"/>
+                <a:ea typeface="Be Vietnam Pro" pitchFamily="34" charset="-122"/>
+                <a:cs typeface="Be Vietnam Pro" pitchFamily="34" charset="-120"/>
+              </a:rPr>
+              <a:t>Bốn</a:t>
+            </a:r>
+            <a:r>
+              <a:rPr lang="en-US" sz="2550" dirty="0" spc="-4" kern="0">
+                <a:solidFill>
+                  <a:srgbClr val="14161C"/>
+                </a:solidFill>
+                <a:latin typeface="Be Vietnam Pro" pitchFamily="34" charset="0"/>
+                <a:ea typeface="Be Vietnam Pro" pitchFamily="34" charset="-122"/>
+                <a:cs typeface="Be Vietnam Pro" pitchFamily="34" charset="-120"/>
+              </a:rPr>
+              <a:t> sự</a:t>
+            </a:r>
+            <a:r>
+              <a:rPr lang="en-US" sz="2550" dirty="0" spc="0" kern="0">
+                <a:solidFill>
+                  <a:srgbClr val="14161C"/>
+                </a:solidFill>
+                <a:latin typeface="Be Vietnam Pro" pitchFamily="34" charset="0"/>
+                <a:ea typeface="Be Vietnam Pro" pitchFamily="34" charset="-122"/>
+                <a:cs typeface="Be Vietnam Pro" pitchFamily="34" charset="-120"/>
+              </a:rPr>
+              <a:t> cố</a:t>
+            </a:r>
+            <a:r>
+              <a:rPr lang="en-US" sz="2550" dirty="0" spc="10" kern="0">
+                <a:solidFill>
+                  <a:srgbClr val="14161C"/>
+                </a:solidFill>
+                <a:latin typeface="Be Vietnam Pro" pitchFamily="34" charset="0"/>
+                <a:ea typeface="Be Vietnam Pro" pitchFamily="34" charset="-122"/>
+                <a:cs typeface="Be Vietnam Pro" pitchFamily="34" charset="-120"/>
+              </a:rPr>
+              <a:t> độc</a:t>
+            </a:r>
+            <a:r>
+              <a:rPr lang="en-US" sz="2550" dirty="0" spc="0" kern="0">
+                <a:solidFill>
+                  <a:srgbClr val="14161C"/>
+                </a:solidFill>
+                <a:latin typeface="Be Vietnam Pro" pitchFamily="34" charset="0"/>
+                <a:ea typeface="Be Vietnam Pro" pitchFamily="34" charset="-122"/>
+                <a:cs typeface="Be Vietnam Pro" pitchFamily="34" charset="-120"/>
+              </a:rPr>
+              <a:t> lập</a:t>
+            </a:r>
+            <a:r>
               <a:rPr lang="en-US" sz="2550" dirty="0" spc="1" kern="0">
                 <a:solidFill>
                   <a:srgbClr val="14161C"/>
@@ -5335,73 +5390,7 @@
                 <a:ea typeface="Be Vietnam Pro" pitchFamily="34" charset="-122"/>
                 <a:cs typeface="Be Vietnam Pro" pitchFamily="34" charset="-120"/>
               </a:rPr>
-              <a:t>Cuối</a:t>
-            </a:r>
-            <a:r>
-              <a:rPr lang="en-US" sz="2550" dirty="0" spc="-1" kern="0">
-                <a:solidFill>
-                  <a:srgbClr val="14161C"/>
-                </a:solidFill>
-                <a:latin typeface="Be Vietnam Pro" pitchFamily="34" charset="0"/>
-                <a:ea typeface="Be Vietnam Pro" pitchFamily="34" charset="-122"/>
-                <a:cs typeface="Be Vietnam Pro" pitchFamily="34" charset="-120"/>
-              </a:rPr>
-              <a:t> bài:</a:t>
-            </a:r>
-            <a:r>
-              <a:rPr lang="en-US" sz="2550" dirty="0" spc="-6" kern="0">
-                <a:solidFill>
-                  <a:srgbClr val="14161C"/>
-                </a:solidFill>
-                <a:latin typeface="Be Vietnam Pro" pitchFamily="34" charset="0"/>
-                <a:ea typeface="Be Vietnam Pro" pitchFamily="34" charset="-122"/>
-                <a:cs typeface="Be Vietnam Pro" pitchFamily="34" charset="-120"/>
-              </a:rPr>
-              <a:t> một</a:t>
-            </a:r>
-            <a:r>
-              <a:rPr lang="en-US" sz="2550" dirty="0" spc="-11" kern="0">
-                <a:solidFill>
-                  <a:srgbClr val="14161C"/>
-                </a:solidFill>
-                <a:latin typeface="Be Vietnam Pro" pitchFamily="34" charset="0"/>
-                <a:ea typeface="Be Vietnam Pro" pitchFamily="34" charset="-122"/>
-                <a:cs typeface="Be Vietnam Pro" pitchFamily="34" charset="-120"/>
-              </a:rPr>
-              <a:t> tệp</a:t>
-            </a:r>
-            <a:r>
-              <a:rPr lang="en-US" sz="2550" dirty="0" spc="-5" kern="0">
-                <a:solidFill>
-                  <a:srgbClr val="14161C"/>
-                </a:solidFill>
-                <a:latin typeface="Be Vietnam Pro" pitchFamily="34" charset="0"/>
-                <a:ea typeface="Be Vietnam Pro" pitchFamily="34" charset="-122"/>
-                <a:cs typeface="Be Vietnam Pro" pitchFamily="34" charset="-120"/>
-              </a:rPr>
-              <a:t> Compose</a:t>
-            </a:r>
-            <a:r>
-              <a:rPr lang="en-US" sz="2550" dirty="0" spc="1" kern="0">
-                <a:solidFill>
-                  <a:srgbClr val="14161C"/>
-                </a:solidFill>
-                <a:latin typeface="Be Vietnam Pro" pitchFamily="34" charset="0"/>
-                <a:ea typeface="Be Vietnam Pro" pitchFamily="34" charset="-122"/>
-                <a:cs typeface="Be Vietnam Pro" pitchFamily="34" charset="-120"/>
-              </a:rPr>
-              <a:t> ghép cả</a:t>
-            </a:r>
-            <a:r>
-              <a:rPr lang="en-US" sz="2550" dirty="0" spc="-2" kern="0">
-                <a:solidFill>
-                  <a:srgbClr val="14161C"/>
-                </a:solidFill>
-                <a:latin typeface="Be Vietnam Pro" pitchFamily="34" charset="0"/>
-                <a:ea typeface="Be Vietnam Pro" pitchFamily="34" charset="-122"/>
-                <a:cs typeface="Be Vietnam Pro" pitchFamily="34" charset="-120"/>
-              </a:rPr>
-              <a:t> bốn.</a:t>
+              <a:t> nhau.</a:t>
             </a:r>
             <a:endParaRPr lang="en-US" sz="2550" dirty="0"/>
           </a:p>

</xml_diff>